<commit_message>
Owner deck: technical, concise wording
Co-Authored-By: Claude Opus 5.5 <noreply@anthropic.com>
Claude-Session: https://claude.ai/code/session_019DhPojZLRqLyCNxgD7HVTj
</commit_message>
<xml_diff>
--- a/build/reports/informes/Informe_Meta_Ads_Orchid_2026-10-12.pptx
+++ b/build/reports/informes/Informe_Meta_Ads_Orchid_2026-10-12.pptx
@@ -118,37 +118,37 @@
   <p:extLst>
     <p:ext uri="{521415D9-36F7-43E2-AB2F-B90AF26B5E84}">
       <p14:sectionLst xmlns:p14="http://schemas.microsoft.com/office/powerpoint/2010/main">
-        <p14:section name="Resumen" id="{f346f9f7-986e-3c62-bf5b-6d2ea2fec6e3}">
+        <p14:section name="Resumen" id="{6f914353-7174-81ba-764e-f7d819d33f31}">
           <p14:sldIdLst>
             <p14:sldId id="256"/>
             <p14:sldId id="257"/>
           </p14:sldIdLst>
         </p14:section>
-        <p14:section name="Resultados" id="{3d479de7-8898-77c8-64c6-d463d5d6b43c}">
+        <p14:section name="Resultados" id="{6f7e0170-f4ad-aead-fbfb-670bdf5efb98}">
           <p14:sldIdLst>
             <p14:sldId id="258"/>
             <p14:sldId id="259"/>
           </p14:sldIdLst>
         </p14:section>
-        <p14:section name="Qué hicimos" id="{4f9b72b1-7f96-c33c-b135-10fd4ec9f026}">
+        <p14:section name="Qué hicimos" id="{6c6e38f4-c2a2-4fe7-cda8-78467961f165}">
           <p14:sldIdLst>
             <p14:sldId id="260"/>
             <p14:sldId id="261"/>
           </p14:sldIdLst>
         </p14:section>
-        <p14:section name="Aprendizajes" id="{21803d57-8c52-9cbf-c15a-68b3850957e6}">
+        <p14:section name="Aprendizajes" id="{7536cfe1-3e4b-48e4-bdc1-5ac35f2912bd}">
           <p14:sldIdLst>
             <p14:sldId id="262"/>
           </p14:sldIdLst>
         </p14:section>
-        <p14:section name="Anuncios" id="{a7b91a82-eecc-9dba-687c-980c92f98b9a}">
+        <p14:section name="Anuncios" id="{47484183-e717-cd62-f9c1-460b1534cd9f}">
           <p14:sldIdLst>
             <p14:sldId id="263"/>
             <p14:sldId id="264"/>
             <p14:sldId id="265"/>
           </p14:sldIdLst>
         </p14:section>
-        <p14:section name="Próximos pasos" id="{aba67608-c7af-26a7-b45a-1b8975bcbba2}">
+        <p14:section name="Próximos pasos" id="{576c564e-d721-b2ae-26e3-8cb41c738ff5}">
           <p14:sldIdLst>
             <p14:sldId id="266"/>
             <p14:sldId id="267"/>
@@ -184,7 +184,7 @@
               <c:strCache>
                 <c:ptCount val="1"/>
                 <c:pt idx="0">
-                  <c:v>Clics al enlace</c:v>
+                  <c:v>Clics en el enlace</c:v>
                 </c:pt>
               </c:strCache>
             </c:strRef>
@@ -261,7 +261,7 @@
               <c:strCache>
                 <c:ptCount val="1"/>
                 <c:pt idx="0">
-                  <c:v>Visitas a la página</c:v>
+                  <c:v>Landing page views</c:v>
                 </c:pt>
               </c:strCache>
             </c:strRef>
@@ -620,10 +620,10 @@
               <c:strCache>
                 <c:ptCount val="2"/>
                 <c:pt idx="0">
-                  <c:v>Buscan trabajo</c:v>
+                  <c:v>No calificado (busca empleo)</c:v>
                 </c:pt>
                 <c:pt idx="1">
-                  <c:v>Quieren contratar</c:v>
+                  <c:v>Calificado</c:v>
                 </c:pt>
               </c:strCache>
             </c:strRef>
@@ -1085,7 +1085,7 @@
           <a:p>
             <a:r>
               <a:rPr lang="en-US" dirty="0"/>
-              <a:t>Informe de las dos primeras semanas de la campaña de Meta Ads de Orchid, con lo que se hizo, lo que aprendimos y las decisiones que necesitamos.</a:t>
+              <a:t>Desempeño de la campaña Leads – Hire VA, semanas 1 y 2: resultados, calidad de leads, cambios, hallazgos y decisiones pendientes.</a:t>
             </a:r>
             <a:endParaRPr lang="en-US" dirty="0"/>
           </a:p>
@@ -1173,7 +1173,7 @@
           <a:p>
             <a:r>
               <a:rPr lang="en-US" dirty="0"/>
-              <a:t>Ninguno trajo leads. S6 se pausó porque 'What does a Virtual Assistant do?' también le habla a quien busca ese trabajo.</a:t>
+              <a:t>Sin leads. S6 pausado: el hook 'What does a Virtual Assistant do?' también atrae candidatos.</a:t>
             </a:r>
             <a:endParaRPr lang="en-US" dirty="0"/>
           </a:p>
@@ -1261,7 +1261,7 @@
           <a:p>
             <a:r>
               <a:rPr lang="en-US" dirty="0"/>
-              <a:t>El próximo informe sale el lunes 19 de octubre con la semana del 12 al 18.</a:t>
+              <a:t>Próximo reporte: lunes 19 oct (semana 12–18 oct).</a:t>
             </a:r>
             <a:endParaRPr lang="en-US" dirty="0"/>
           </a:p>
@@ -1349,7 +1349,7 @@
           <a:p>
             <a:r>
               <a:rPr lang="en-US" dirty="0"/>
-              <a:t>Con estas tres respuestas podemos fijar metas claras para las próximas semanas.</a:t>
+              <a:t>Insumos necesarios para fijar metas de las próximas semanas.</a:t>
             </a:r>
             <a:endParaRPr lang="en-US" dirty="0"/>
           </a:p>
@@ -1437,7 +1437,7 @@
           <a:p>
             <a:r>
               <a:rPr lang="en-US" dirty="0"/>
-              <a:t>Mensaje principal: en dos semanas, un solo lead real. La causa está identificada y corregida el 12 de octubre.</a:t>
+              <a:t>1 lead calificado en 2 semanas. Causa identificada (reasignación de presupuesto a S3) y corregida el 12 oct.</a:t>
             </a:r>
             <a:endParaRPr lang="en-US" dirty="0"/>
           </a:p>
@@ -1525,7 +1525,7 @@
           <a:p>
             <a:r>
               <a:rPr lang="en-US" dirty="0"/>
-              <a:t>Con un gasto parecido, la semana 2 bajó de 183 a 53 clics y de 145 a 38 visitas a la página, y no trajo ningún lead que quisiera contratar.</a:t>
+              <a:t>Semana 2: CTR 6.46% → 2.21%, CPM $74.49 → $115.40, 0 leads calificados.</a:t>
             </a:r>
             <a:endParaRPr lang="en-US" dirty="0"/>
           </a:p>
@@ -1613,7 +1613,7 @@
           <a:p>
             <a:r>
               <a:rPr lang="en-US" dirty="0"/>
-              <a:t>Quien busca trabajo suele mentir en las demás preguntas del formulario; la única que lo delata es 'Hiring or job seeking'. Meta cuenta a todos como lead, por eso medimos con GHL.</a:t>
+              <a:t>El campo 'Hiring or job seeking' es el único filtro confiable; las demás respuestas de los no calificados son inconsistentes. KPI: lead calificado en GHL.</a:t>
             </a:r>
             <a:endParaRPr lang="en-US" dirty="0"/>
           </a:p>
@@ -1701,7 +1701,7 @@
           <a:p>
             <a:r>
               <a:rPr lang="en-US" dirty="0"/>
-              <a:t>El 11 de octubre se pausó el video V2, el único que trajo un cliente; no quedó registrado el motivo.</a:t>
+              <a:t>11 oct: se pausó V2, único anuncio con lead calificado. Motivo no documentado.</a:t>
             </a:r>
             <a:endParaRPr lang="en-US" dirty="0"/>
           </a:p>
@@ -1789,7 +1789,7 @@
           <a:p>
             <a:r>
               <a:rPr lang="en-US" dirty="0"/>
-              <a:t>Además, el equipo simplificó el formulario de GHL el mismo día.</a:t>
+              <a:t>Formulario de GHL simplificado el mismo día.</a:t>
             </a:r>
             <a:endParaRPr lang="en-US" dirty="0"/>
           </a:p>
@@ -1877,7 +1877,7 @@
           <a:p>
             <a:r>
               <a:rPr lang="en-US" dirty="0"/>
-              <a:t>Advantage+ Audience también gastaba en personas de 18 a 34 años; ya está apagado.</a:t>
+              <a:t>Advantage+ Audience asignaba gasto fuera del rango 30–65; desactivado.</a:t>
             </a:r>
             <a:endParaRPr lang="en-US" dirty="0"/>
           </a:p>
@@ -1965,7 +1965,7 @@
           <a:p>
             <a:r>
               <a:rPr lang="en-US" dirty="0"/>
-              <a:t>Las capturas muestran cómo se ve cada anuncio en el feed del celular desde el 12 de octubre.</a:t>
+              <a:t>Vista previa en feed móvil con el copy vigente desde el 12 oct.</a:t>
             </a:r>
             <a:endParaRPr lang="en-US" dirty="0"/>
           </a:p>
@@ -2053,7 +2053,7 @@
           <a:p>
             <a:r>
               <a:rPr lang="en-US" dirty="0"/>
-              <a:t>Ninguno de los dos trajo a alguien que quisiera contratar.</a:t>
+              <a:t>0 leads calificados entre ambos.</a:t>
             </a:r>
             <a:endParaRPr lang="en-US" dirty="0"/>
           </a:p>
@@ -2915,7 +2915,7 @@
                   <a:schemeClr val="accent1"/>
                 </a:solidFill>
               </a:rPr>
-              <a:t>Del 29 de septiembre al 11 de octubre de 2026</a:t>
+              <a:t>Periodo: 29 sep – 11 oct 2026</a:t>
             </a:r>
             <a:endParaRPr lang="en-US" sz="1800" dirty="0"/>
           </a:p>
@@ -2929,7 +2929,7 @@
                   <a:schemeClr val="bg1"/>
                 </a:solidFill>
               </a:rPr>
-              <a:t>Preparado para la dirección de Orchid · 12 de octubre de 2026</a:t>
+              <a:t>Reporte de desempeño · Dirección de Orchid · 12 oct 2026</a:t>
             </a:r>
             <a:endParaRPr lang="en-US" sz="1800" dirty="0"/>
           </a:p>
@@ -2992,7 +2992,7 @@
                   <a:schemeClr val="tx2"/>
                 </a:solidFill>
               </a:rPr>
-              <a:t>Otros anuncios pausados</a:t>
+              <a:t>Creativos pausados sin conversiones</a:t>
             </a:r>
             <a:endParaRPr lang="en-US" sz="3000" dirty="0"/>
           </a:p>
@@ -3615,7 +3615,7 @@
                   <a:schemeClr val="tx2"/>
                 </a:solidFill>
               </a:rPr>
-              <a:t>Plan para esta semana (12 – 18 oct)</a:t>
+              <a:t>Plan · 12 – 18 oct</a:t>
             </a:r>
             <a:endParaRPr lang="en-US" sz="3000" dirty="0"/>
           </a:p>
@@ -3742,7 +3742,7 @@
                 <a:ea typeface="Cambria" pitchFamily="34" charset="-122"/>
                 <a:cs typeface="Cambria" pitchFamily="34" charset="-120"/>
               </a:rPr>
-              <a:t>Dejar que Meta aprenda</a:t>
+              <a:t>Fase de aprendizaje</a:t>
             </a:r>
             <a:endParaRPr lang="en-US" sz="1700" dirty="0"/>
           </a:p>
@@ -3778,7 +3778,7 @@
                   <a:schemeClr val="tx1"/>
                 </a:solidFill>
               </a:rPr>
-              <a:t>No tocar la campaña durante 5 días. Solo pausar un anuncio si gasta unos $120 sin traer un lead que quiera contratar.</a:t>
+              <a:t>Sin cambios durante 5 días. Criterio de pausa: ~$120 de gasto sin lead calificado.</a:t>
             </a:r>
             <a:endParaRPr lang="en-US" sz="1300" dirty="0"/>
           </a:p>
@@ -3905,7 +3905,7 @@
                 <a:ea typeface="Cambria" pitchFamily="34" charset="-122"/>
                 <a:cs typeface="Cambria" pitchFamily="34" charset="-120"/>
               </a:rPr>
-              <a:t>Medir cada lead en GHL</a:t>
+              <a:t>Medición en GHL</a:t>
             </a:r>
             <a:endParaRPr lang="en-US" sz="1700" dirty="0"/>
           </a:p>
@@ -3941,7 +3941,7 @@
                   <a:schemeClr val="tx1"/>
                 </a:solidFill>
               </a:rPr>
-              <a:t>La alerta diaria (martes a viernes) separa a quien quiere contratar de quien busca trabajo, por anuncio.</a:t>
+              <a:t>Reporte diario de leads calificados vs. no calificados por anuncio.</a:t>
             </a:r>
             <a:endParaRPr lang="en-US" sz="1300" dirty="0"/>
           </a:p>
@@ -4068,7 +4068,7 @@
                 <a:ea typeface="Cambria" pitchFamily="34" charset="-122"/>
                 <a:cs typeface="Cambria" pitchFamily="34" charset="-120"/>
               </a:rPr>
-              <a:t>Subir creativos nuevos</a:t>
+              <a:t>Nuevos creativos</a:t>
             </a:r>
             <a:endParaRPr lang="en-US" sz="1700" dirty="0"/>
           </a:p>
@@ -4104,7 +4104,7 @@
                   <a:schemeClr val="tx1"/>
                 </a:solidFill>
               </a:rPr>
-              <a:t>Con "For Law Firm Owners" o "For Business Owners" sobre la imagen. En el video de V2, cambiar "19 jobs" por "19 roles".</a:t>
+              <a:t>Texto en imagen dirigido al comprador ("For Law Firm Owners"). V2: reemplazar "19 jobs" por "19 roles".</a:t>
             </a:r>
             <a:endParaRPr lang="en-US" sz="1300" dirty="0"/>
           </a:p>
@@ -4212,7 +4212,7 @@
                   <a:schemeClr val="bg1"/>
                 </a:solidFill>
               </a:rPr>
-              <a:t>Decisiones que necesitamos de ustedes</a:t>
+              <a:t>Decisiones requeridas</a:t>
             </a:r>
             <a:endParaRPr lang="en-US" sz="3000" dirty="0"/>
           </a:p>
@@ -4275,7 +4275,7 @@
                   <a:schemeClr val="accent1"/>
                 </a:solidFill>
               </a:rPr>
-              <a:t>Origen de 3 contactos</a:t>
+              <a:t>Atribución de 3 leads del 11 oct</a:t>
             </a:r>
             <a:endParaRPr lang="en-US" sz="1800" dirty="0"/>
           </a:p>
@@ -4311,7 +4311,7 @@
                   <a:schemeClr val="bg1"/>
                 </a:solidFill>
               </a:rPr>
-              <a:t>¿Los 3 contactos que agendaron la noche del 11 de octubre vinieron de otro canal o fueron pruebas del formulario?</a:t>
+              <a:t>Confirmar si provienen de otro canal o de pruebas del formulario.</a:t>
             </a:r>
             <a:endParaRPr lang="en-US" sz="1400" dirty="0"/>
           </a:p>
@@ -4374,7 +4374,7 @@
                   <a:schemeClr val="accent1"/>
                 </a:solidFill>
               </a:rPr>
-              <a:t>Costo máximo por lead calificado</a:t>
+              <a:t>CPL calificado objetivo</a:t>
             </a:r>
             <a:endParaRPr lang="en-US" sz="1800" dirty="0"/>
           </a:p>
@@ -4410,7 +4410,7 @@
                   <a:schemeClr val="bg1"/>
                 </a:solidFill>
               </a:rPr>
-              <a:t>¿Cuánto están dispuestos a pagar por cada lead que quiere contratar? Ese número define cuándo escalar o pausar.</a:t>
+              <a:t>Definir el máximo aceptable. Determina los umbrales de escalado y pausa.</a:t>
             </a:r>
             <a:endParaRPr lang="en-US" sz="1400" dirty="0"/>
           </a:p>
@@ -4473,7 +4473,7 @@
                   <a:schemeClr val="accent1"/>
                 </a:solidFill>
               </a:rPr>
-              <a:t>Evento "Lead" solo para compradores</a:t>
+              <a:t>Optimización por lead calificado</a:t>
             </a:r>
             <a:endParaRPr lang="en-US" sz="1800" dirty="0"/>
           </a:p>
@@ -4509,7 +4509,7 @@
                   <a:schemeClr val="bg1"/>
                 </a:solidFill>
               </a:rPr>
-              <a:t>¿Aprueban que GHL avise a Meta de un lead solo cuando la persona responde "I want to hire."? Así Meta aprende de compradores.</a:t>
+              <a:t>Aprobar el envío del evento Lead vía CAPI solo cuando la respuesta es "I want to hire.".</a:t>
             </a:r>
             <a:endParaRPr lang="en-US" sz="1400" dirty="0"/>
           </a:p>
@@ -4617,7 +4617,7 @@
                   <a:schemeClr val="tx2"/>
                 </a:solidFill>
               </a:rPr>
-              <a:t>Dos semanas en tres números</a:t>
+              <a:t>Resumen ejecutivo</a:t>
             </a:r>
             <a:endParaRPr lang="en-US" sz="3000" dirty="0"/>
           </a:p>
@@ -4719,7 +4719,7 @@
                   <a:schemeClr val="tx1"/>
                 </a:solidFill>
               </a:rPr>
-              <a:t>Inversión total en Meta</a:t>
+              <a:t>Inversión</a:t>
             </a:r>
             <a:endParaRPr lang="en-US" sz="1500" dirty="0"/>
           </a:p>
@@ -4857,7 +4857,7 @@
                   <a:schemeClr val="tx1"/>
                 </a:solidFill>
               </a:rPr>
-              <a:t>Lead que quiere contratar</a:t>
+              <a:t>Lead calificado</a:t>
             </a:r>
             <a:endParaRPr lang="en-US" sz="1500" dirty="0"/>
           </a:p>
@@ -4893,7 +4893,7 @@
                   <a:schemeClr val="accent6"/>
                 </a:solidFill>
               </a:rPr>
-              <a:t>Llegó por el video V2 y agendó llamada</a:t>
+              <a:t>V2 · llamada agendada</a:t>
             </a:r>
             <a:endParaRPr lang="en-US" sz="1100" dirty="0"/>
           </a:p>
@@ -4995,7 +4995,7 @@
                   <a:schemeClr val="tx1"/>
                 </a:solidFill>
               </a:rPr>
-              <a:t>Costo por lead calificado</a:t>
+              <a:t>CPL calificado</a:t>
             </a:r>
             <a:endParaRPr lang="en-US" sz="1500" dirty="0"/>
           </a:p>
@@ -5031,7 +5031,7 @@
                   <a:schemeClr val="accent6"/>
                 </a:solidFill>
               </a:rPr>
-              <a:t>Inversión ÷ leads que quieren contratar</a:t>
+              <a:t>Inversión ÷ leads calificados</a:t>
             </a:r>
             <a:endParaRPr lang="en-US" sz="1100" dirty="0"/>
           </a:p>
@@ -5067,7 +5067,7 @@
                   <a:schemeClr val="tx1"/>
                 </a:solidFill>
               </a:rPr>
-              <a:t>La semana 1 funcionó porque el presupuesto fue al video V2. </a:t>
+              <a:t>Semana 1: delivery concentrado en V2 (82% del gasto). </a:t>
             </a:r>
             <a:pPr indent="0" marL="0">
               <a:buNone/>
@@ -5078,7 +5078,7 @@
                   <a:schemeClr val="tx1"/>
                 </a:solidFill>
               </a:rPr>
-              <a:t>En la semana 2, Meta movió el dinero a un anuncio estático (S3) que atrajo a personas que buscaban trabajo. El 12 de octubre corregimos la audiencia, los anuncios activos y los textos.</a:t>
+              <a:t>Semana 2: el algoritmo reasignó el 75% del gasto a S3 (estático), con tráfico de baja intención y 0 leads calificados. Ajustes de segmentación, creativos y copy aplicados el 12 oct.</a:t>
             </a:r>
             <a:endParaRPr lang="en-US" sz="1500" dirty="0"/>
           </a:p>
@@ -5186,7 +5186,7 @@
                   <a:schemeClr val="tx2"/>
                 </a:solidFill>
               </a:rPr>
-              <a:t>Semana 2: menos de un tercio de los clics</a:t>
+              <a:t>Semana 2: −71% en clics con +31% de inversión</a:t>
             </a:r>
             <a:endParaRPr lang="en-US" sz="3000" dirty="0"/>
           </a:p>
@@ -5510,7 +5510,7 @@
                           <a:ea typeface="Calibri" pitchFamily="34" charset="-122"/>
                           <a:cs typeface="Calibri" pitchFamily="34" charset="-120"/>
                         </a:rPr>
-                        <a:t>Costo por mil impresiones</a:t>
+                        <a:t>CPM</a:t>
                       </a:r>
                       <a:endParaRPr lang="en-US" sz="1200" dirty="0">
                         <a:latin typeface="Calibri" charset="0"/>
@@ -5644,7 +5644,7 @@
                           <a:ea typeface="Calibri" pitchFamily="34" charset="-122"/>
                           <a:cs typeface="Calibri" pitchFamily="34" charset="-120"/>
                         </a:rPr>
-                        <a:t>% que hace clic (CTR)</a:t>
+                        <a:t>CTR (enlace)</a:t>
                       </a:r>
                       <a:endParaRPr lang="en-US" sz="1200" dirty="0">
                         <a:latin typeface="Calibri" charset="0"/>
@@ -5778,7 +5778,7 @@
                           <a:ea typeface="Calibri" pitchFamily="34" charset="-122"/>
                           <a:cs typeface="Calibri" pitchFamily="34" charset="-120"/>
                         </a:rPr>
-                        <a:t>Leads según Meta</a:t>
+                        <a:t>Leads (Meta)</a:t>
                       </a:r>
                       <a:endParaRPr lang="en-US" sz="1200" dirty="0">
                         <a:latin typeface="Calibri" charset="0"/>
@@ -5912,7 +5912,7 @@
                           <a:ea typeface="Calibri" pitchFamily="34" charset="-122"/>
                           <a:cs typeface="Calibri" pitchFamily="34" charset="-120"/>
                         </a:rPr>
-                        <a:t>Quieren contratar (GHL)</a:t>
+                        <a:t>Leads calificados (GHL)</a:t>
                       </a:r>
                       <a:endParaRPr lang="en-US" sz="1200" dirty="0">
                         <a:latin typeface="Calibri" charset="0"/>
@@ -6046,7 +6046,7 @@
                           <a:ea typeface="Calibri" pitchFamily="34" charset="-122"/>
                           <a:cs typeface="Calibri" pitchFamily="34" charset="-120"/>
                         </a:rPr>
-                        <a:t>Buscan trabajo (GHL)</a:t>
+                        <a:t>Leads no calificados (GHL)</a:t>
                       </a:r>
                       <a:endParaRPr lang="en-US" sz="1200" dirty="0">
                         <a:latin typeface="Calibri" charset="0"/>
@@ -6196,7 +6196,7 @@
                   <a:schemeClr val="accent6"/>
                 </a:solidFill>
               </a:rPr>
-              <a:t>La semana 1 tuvo 6 días con anuncios: la campaña arrancó el martes 29.</a:t>
+              <a:t>Semana 1: 6 días de delivery (inicio 29 sep).</a:t>
             </a:r>
             <a:endParaRPr lang="en-US" sz="1000" dirty="0"/>
           </a:p>
@@ -6304,7 +6304,7 @@
                   <a:schemeClr val="tx2"/>
                 </a:solidFill>
               </a:rPr>
-              <a:t>3 de cada 4 leads de anuncios buscaban trabajo</a:t>
+              <a:t>Calidad de leads: 75% no calificados</a:t>
             </a:r>
             <a:endParaRPr lang="en-US" sz="3000" dirty="0"/>
           </a:p>
@@ -6455,7 +6455,7 @@
                   <a:schemeClr val="accent4"/>
                 </a:solidFill>
               </a:rPr>
-              <a:t>Quiere contratar · agendó</a:t>
+              <a:t>Calificado · agendado</a:t>
             </a:r>
             <a:endParaRPr lang="en-US" sz="1200" dirty="0"/>
           </a:p>
@@ -6590,7 +6590,7 @@
                   <a:schemeClr val="accent5"/>
                 </a:solidFill>
               </a:rPr>
-              <a:t>Busca trabajo</a:t>
+              <a:t>No calificado</a:t>
             </a:r>
             <a:endParaRPr lang="en-US" sz="1200" dirty="0"/>
           </a:p>
@@ -6725,7 +6725,7 @@
                   <a:schemeClr val="accent5"/>
                 </a:solidFill>
               </a:rPr>
-              <a:t>Busca trabajo</a:t>
+              <a:t>No calificado</a:t>
             </a:r>
             <a:endParaRPr lang="en-US" sz="1200" dirty="0"/>
           </a:p>
@@ -6860,7 +6860,7 @@
                   <a:schemeClr val="accent5"/>
                 </a:solidFill>
               </a:rPr>
-              <a:t>Busca trabajo</a:t>
+              <a:t>No calificado</a:t>
             </a:r>
             <a:endParaRPr lang="en-US" sz="1200" dirty="0"/>
           </a:p>
@@ -6896,7 +6896,7 @@
                   <a:schemeClr val="tx1"/>
                 </a:solidFill>
               </a:rPr>
-              <a:t>Por confirmar: </a:t>
+              <a:t>Pendiente: </a:t>
             </a:r>
             <a:pPr indent="0" marL="0">
               <a:buNone/>
@@ -6907,7 +6907,7 @@
                   <a:schemeClr val="tx1"/>
                 </a:solidFill>
               </a:rPr>
-              <a:t>la noche del 11 de octubre entraron 3 contactos que quieren contratar y agendaron, pero GHL no registra que vinieran de un anuncio.</a:t>
+              <a:t>3 leads calificados del 11 oct sin atribución (tráfico directo, sin UTM).</a:t>
             </a:r>
             <a:endParaRPr lang="en-US" sz="1200" dirty="0"/>
           </a:p>
@@ -7015,7 +7015,7 @@
                   <a:schemeClr val="tx2"/>
                 </a:solidFill>
               </a:rPr>
-              <a:t>Qué pasó en la cuenta, día por día</a:t>
+              <a:t>Cronología de cambios</a:t>
             </a:r>
             <a:endParaRPr lang="en-US" sz="3000" dirty="0"/>
           </a:p>
@@ -7210,7 +7210,7 @@
                   <a:schemeClr val="tx1"/>
                 </a:solidFill>
               </a:rPr>
-              <a:t>4 videos y 2 carruseles hacia go.orchidpros.com/hire.</a:t>
+              <a:t>Campaña ABO, objetivo Leads. 4 videos y 2 carruseles.</a:t>
             </a:r>
             <a:endParaRPr lang="en-US" sz="1300" dirty="0"/>
           </a:p>
@@ -7346,7 +7346,7 @@
                 <a:ea typeface="Cambria" pitchFamily="34" charset="-122"/>
                 <a:cs typeface="Cambria" pitchFamily="34" charset="-120"/>
               </a:rPr>
-              <a:t>Más variedad</a:t>
+              <a:t>Expansión creativa</a:t>
             </a:r>
             <a:endParaRPr lang="en-US" sz="1700" dirty="0"/>
           </a:p>
@@ -7382,7 +7382,7 @@
                   <a:schemeClr val="tx1"/>
                 </a:solidFill>
               </a:rPr>
-              <a:t>Se suman 8 anuncios estáticos (S1–S8).</a:t>
+              <a:t>+8 estáticos (S1–S8).</a:t>
             </a:r>
             <a:endParaRPr lang="en-US" sz="1300" dirty="0"/>
           </a:p>
@@ -7554,7 +7554,7 @@
                   <a:schemeClr val="tx1"/>
                 </a:solidFill>
               </a:rPr>
-              <a:t>El equipo pausa los videos y deja solo 3 estáticos activos.</a:t>
+              <a:t>Pausa de videos y carruseles; activos solo S1, S6 y S8.</a:t>
             </a:r>
             <a:endParaRPr lang="en-US" sz="1300" dirty="0"/>
           </a:p>
@@ -7690,7 +7690,7 @@
                 <a:ea typeface="Cambria" pitchFamily="34" charset="-122"/>
                 <a:cs typeface="Cambria" pitchFamily="34" charset="-120"/>
               </a:rPr>
-              <a:t>Correcciones</a:t>
+              <a:t>Optimización</a:t>
             </a:r>
             <a:endParaRPr lang="en-US" sz="1700" dirty="0"/>
           </a:p>
@@ -7726,7 +7726,7 @@
                   <a:schemeClr val="tx1"/>
                 </a:solidFill>
               </a:rPr>
-              <a:t>Medimos con GHL y corregimos audiencia, anuncios y textos.</a:t>
+              <a:t>Integración con GHL; ajustes de segmentación, creativos y copy.</a:t>
             </a:r>
             <a:endParaRPr lang="en-US" sz="1300" dirty="0"/>
           </a:p>
@@ -7834,7 +7834,7 @@
                   <a:schemeClr val="tx2"/>
                 </a:solidFill>
               </a:rPr>
-              <a:t>Las correcciones del 12 de octubre</a:t>
+              <a:t>Optimización del 12 oct</a:t>
             </a:r>
             <a:endParaRPr lang="en-US" sz="3000" dirty="0"/>
           </a:p>
@@ -8001,7 +8001,7 @@
                   <a:schemeClr val="tx1"/>
                 </a:solidFill>
               </a:rPr>
-              <a:t>Apagamos Advantage+ Audience: Meta estaba llegando a personas de 18–34 años.</a:t>
+              <a:t>Advantage+ Audience desactivado (gasto en 18–34).</a:t>
             </a:r>
             <a:endParaRPr lang="en-US" sz="1300" dirty="0"/>
           </a:p>
@@ -8019,7 +8019,7 @@
                   <a:schemeClr val="tx1"/>
                 </a:solidFill>
               </a:rPr>
-              <a:t>Edad fija de 30 a 65 años.</a:t>
+              <a:t>Edad 30–65 como límite estricto.</a:t>
             </a:r>
             <a:endParaRPr lang="en-US" sz="1300" dirty="0"/>
           </a:p>
@@ -8037,7 +8037,7 @@
                   <a:schemeClr val="tx1"/>
                 </a:solidFill>
               </a:rPr>
-              <a:t>Solo personas que viven en EE. UU.</a:t>
+              <a:t>Ubicación: residentes en EE. UU.</a:t>
             </a:r>
             <a:endParaRPr lang="en-US" sz="1300" dirty="0"/>
           </a:p>
@@ -8204,7 +8204,7 @@
                   <a:schemeClr val="tx1"/>
                 </a:solidFill>
               </a:rPr>
-              <a:t>Reactivamos V2, el único que trajo un cliente real.</a:t>
+              <a:t>V2 reactivado (único con lead calificado).</a:t>
             </a:r>
             <a:endParaRPr lang="en-US" sz="1300" dirty="0"/>
           </a:p>
@@ -8222,7 +8222,7 @@
                   <a:schemeClr val="tx1"/>
                 </a:solidFill>
               </a:rPr>
-              <a:t>Reactivamos V1, el de mejor tasa de clics.</a:t>
+              <a:t>V1 reactivado (CTR 28%).</a:t>
             </a:r>
             <a:endParaRPr lang="en-US" sz="1300" dirty="0"/>
           </a:p>
@@ -8240,7 +8240,7 @@
                   <a:schemeClr val="tx1"/>
                 </a:solidFill>
               </a:rPr>
-              <a:t>Pausamos S1 y S6; S8 sigue activo.</a:t>
+              <a:t>S1 y S6 pausados; S8 activo.</a:t>
             </a:r>
             <a:endParaRPr lang="en-US" sz="1300" dirty="0"/>
           </a:p>
@@ -8367,7 +8367,7 @@
                 <a:ea typeface="Cambria" pitchFamily="34" charset="-122"/>
                 <a:cs typeface="Cambria" pitchFamily="34" charset="-120"/>
               </a:rPr>
-              <a:t>Textos</a:t>
+              <a:t>Copy</a:t>
             </a:r>
             <a:endParaRPr lang="en-US" sz="1800" dirty="0"/>
           </a:p>
@@ -8407,7 +8407,7 @@
                   <a:schemeClr val="tx1"/>
                 </a:solidFill>
               </a:rPr>
-              <a:t>La primera línea le habla a quien contrata: "Law firm owners:", "Business owners:".</a:t>
+              <a:t>Hook dirigido al comprador ("Law firm owners:").</a:t>
             </a:r>
             <a:endParaRPr lang="en-US" sz="1300" dirty="0"/>
           </a:p>
@@ -8443,7 +8443,7 @@
                   <a:schemeClr val="tx1"/>
                 </a:solidFill>
               </a:rPr>
-              <a:t>Sin palabras de empleo.</a:t>
+              <a:t>Sin términos asociados a empleo.</a:t>
             </a:r>
             <a:endParaRPr lang="en-US" sz="1300" dirty="0"/>
           </a:p>
@@ -8479,7 +8479,7 @@
                   <a:schemeClr val="accent6"/>
                 </a:solidFill>
               </a:rPr>
-              <a:t>También intentamos excluir intereses de empleo (Indeed, Job hunting): Meta ya no lo permite.</a:t>
+              <a:t>Exclusión de intereses de empleo no disponible: Meta retiró las exclusiones de segmentación detallada.</a:t>
             </a:r>
             <a:endParaRPr lang="en-US" sz="1100" dirty="0"/>
           </a:p>
@@ -8587,7 +8587,7 @@
                   <a:schemeClr val="tx2"/>
                 </a:solidFill>
               </a:rPr>
-              <a:t>Qué aprendimos</a:t>
+              <a:t>Hallazgos</a:t>
             </a:r>
             <a:endParaRPr lang="en-US" sz="3000" dirty="0"/>
           </a:p>
@@ -8684,7 +8684,7 @@
                   <a:schemeClr val="tx2"/>
                 </a:solidFill>
               </a:rPr>
-              <a:t>El video para abogados (V2) es el único anuncio que trajo un cliente real.</a:t>
+              <a:t>V2 es el único creativo con lead calificado.</a:t>
             </a:r>
             <a:endParaRPr lang="en-US" sz="1600" dirty="0"/>
           </a:p>
@@ -8720,7 +8720,7 @@
                   <a:schemeClr val="tx1"/>
                 </a:solidFill>
               </a:rPr>
-              <a:t>Recibió el 82% del presupuesto en la semana 1 y solo el 21% en la semana 2.</a:t>
+              <a:t>Share de gasto: 82% en semana 1, 21% en semana 2.</a:t>
             </a:r>
             <a:endParaRPr lang="en-US" sz="1300" dirty="0"/>
           </a:p>
@@ -8817,7 +8817,7 @@
                   <a:schemeClr val="tx2"/>
                 </a:solidFill>
               </a:rPr>
-              <a:t>El estático S3 atrajo a quien busca trabajo.</a:t>
+              <a:t>S3 genera tráfico de baja intención.</a:t>
             </a:r>
             <a:endParaRPr lang="en-US" sz="1600" dirty="0"/>
           </a:p>
@@ -8853,7 +8853,7 @@
                   <a:schemeClr val="tx1"/>
                 </a:solidFill>
               </a:rPr>
-              <a:t>Gastó $207.45 en la semana 2, con CTR de 1.6%; sus 2 leads buscaban empleo.</a:t>
+              <a:t>$207.45 en semana 2, CTR 1.6%, 2 leads no calificados.</a:t>
             </a:r>
             <a:endParaRPr lang="en-US" sz="1300" dirty="0"/>
           </a:p>
@@ -8950,7 +8950,7 @@
                   <a:schemeClr val="tx2"/>
                 </a:solidFill>
               </a:rPr>
-              <a:t>El "lead" que reporta Meta no mide el éxito.</a:t>
+              <a:t>El evento Lead de Meta no refleja calidad.</a:t>
             </a:r>
             <a:endParaRPr lang="en-US" sz="1600" dirty="0"/>
           </a:p>
@@ -8986,7 +8986,7 @@
                   <a:schemeClr val="tx1"/>
                 </a:solidFill>
               </a:rPr>
-              <a:t>Desde ahora medimos con GHL: leads que quieren contratar y su costo.</a:t>
+              <a:t>3 de 4 leads atribuidos no calificados. KPI: CPL calificado (GHL).</a:t>
             </a:r>
             <a:endParaRPr lang="en-US" sz="1300" dirty="0"/>
           </a:p>
@@ -9083,7 +9083,7 @@
                   <a:schemeClr val="tx2"/>
                 </a:solidFill>
               </a:rPr>
-              <a:t>V1 y V4 tienen las mejores tasas de clic (23–29%), pero casi no recibieron presupuesto.</a:t>
+              <a:t>V1 y V4: CTR de 23–29% con gasto marginal.</a:t>
             </a:r>
             <a:endParaRPr lang="en-US" sz="1600" dirty="0"/>
           </a:p>
@@ -9119,7 +9119,7 @@
                   <a:schemeClr val="tx1"/>
                 </a:solidFill>
               </a:rPr>
-              <a:t>Todavía no sabemos si traen clientes; V1 vuelve a estar activo para probarlo.</a:t>
+              <a:t>Sin volumen para evaluar conversión; V1 reactivado en prueba.</a:t>
             </a:r>
             <a:endParaRPr lang="en-US" sz="1300" dirty="0"/>
           </a:p>
@@ -9227,7 +9227,7 @@
                   <a:schemeClr val="tx2"/>
                 </a:solidFill>
               </a:rPr>
-              <a:t>Los 3 anuncios activos, con el texto nuevo</a:t>
+              <a:t>Creativos activos (copy v3)</a:t>
             </a:r>
             <a:endParaRPr lang="en-US" sz="3000" dirty="0"/>
           </a:p>
@@ -9366,7 +9366,7 @@
                   <a:schemeClr val="accent4"/>
                 </a:solidFill>
               </a:rPr>
-              <a:t>1 quiere contratar (agendó)</a:t>
+              <a:t>1 lead calificado (agendado)</a:t>
             </a:r>
             <a:endParaRPr lang="en-US" sz="1200" dirty="0"/>
           </a:p>
@@ -9505,7 +9505,7 @@
                   <a:schemeClr val="accent6"/>
                 </a:solidFill>
               </a:rPr>
-              <a:t>Sin leads aún; a prueba</a:t>
+              <a:t>Sin leads · en prueba</a:t>
             </a:r>
             <a:endParaRPr lang="en-US" sz="1200" dirty="0"/>
           </a:p>
@@ -9644,7 +9644,7 @@
                   <a:schemeClr val="accent6"/>
                 </a:solidFill>
               </a:rPr>
-              <a:t>Sin leads aún</a:t>
+              <a:t>Sin leads</a:t>
             </a:r>
             <a:endParaRPr lang="en-US" sz="1200" dirty="0"/>
           </a:p>
@@ -9680,7 +9680,7 @@
                   <a:schemeClr val="accent6"/>
                 </a:solidFill>
               </a:rPr>
-              <a:t>Cifras acumuladas del 29 sep al 11 oct. En los videos se ve la portada.</a:t>
+              <a:t>Acumulado 29 sep – 11 oct. En videos se muestra la miniatura.</a:t>
             </a:r>
             <a:endParaRPr lang="en-US" sz="1000" dirty="0"/>
           </a:p>
@@ -9788,7 +9788,7 @@
                   <a:schemeClr val="tx2"/>
                 </a:solidFill>
               </a:rPr>
-              <a:t>Los que trajeron buscadores de empleo</a:t>
+              <a:t>Creativos con leads no calificados</a:t>
             </a:r>
             <a:endParaRPr lang="en-US" sz="3000" dirty="0"/>
           </a:p>
@@ -9927,7 +9927,7 @@
                   <a:schemeClr val="accent5"/>
                 </a:solidFill>
               </a:rPr>
-              <a:t>2 buscan trabajo</a:t>
+              <a:t>2 leads no calificados</a:t>
             </a:r>
             <a:endParaRPr lang="en-US" sz="1300" dirty="0"/>
           </a:p>
@@ -9963,7 +9963,7 @@
                   <a:schemeClr val="tx1"/>
                 </a:solidFill>
               </a:rPr>
-              <a:t>Se llevó el 75% del presupuesto de la semana 2.</a:t>
+              <a:t>75% del gasto de la semana 2.</a:t>
             </a:r>
             <a:endParaRPr lang="en-US" sz="1200" dirty="0"/>
           </a:p>
@@ -10138,7 +10138,7 @@
                   <a:schemeClr val="accent5"/>
                 </a:solidFill>
               </a:rPr>
-              <a:t>1 busca trabajo</a:t>
+              <a:t>1 lead no calificado</a:t>
             </a:r>
             <a:endParaRPr lang="en-US" sz="1300" dirty="0"/>
           </a:p>
@@ -10174,7 +10174,7 @@
                   <a:schemeClr val="tx1"/>
                 </a:solidFill>
               </a:rPr>
-              <a:t>Promete un "regalo" que atrae curiosos.</a:t>
+              <a:t>Oferta tipo "regalo": tráfico de baja intención.</a:t>
             </a:r>
             <a:endParaRPr lang="en-US" sz="1200" dirty="0"/>
           </a:p>

</xml_diff>